<commit_message>
Added illustrations of each question
</commit_message>
<xml_diff>
--- a/assets/images/Experitments_Procedures_General_Questionnaire.pptx
+++ b/assets/images/Experitments_Procedures_General_Questionnaire.pptx
@@ -5,11 +5,22 @@
     <p:sldMasterId id="2147483684" r:id="rId4"/>
   </p:sldMasterIdLst>
   <p:notesMasterIdLst>
-    <p:notesMasterId r:id="rId7"/>
+    <p:notesMasterId r:id="rId18"/>
   </p:notesMasterIdLst>
   <p:sldIdLst>
     <p:sldId id="256" r:id="rId5"/>
     <p:sldId id="257" r:id="rId6"/>
+    <p:sldId id="258" r:id="rId7"/>
+    <p:sldId id="259" r:id="rId8"/>
+    <p:sldId id="260" r:id="rId9"/>
+    <p:sldId id="261" r:id="rId10"/>
+    <p:sldId id="262" r:id="rId11"/>
+    <p:sldId id="263" r:id="rId12"/>
+    <p:sldId id="264" r:id="rId13"/>
+    <p:sldId id="265" r:id="rId14"/>
+    <p:sldId id="266" r:id="rId15"/>
+    <p:sldId id="267" r:id="rId16"/>
+    <p:sldId id="268" r:id="rId17"/>
   </p:sldIdLst>
   <p:sldSz cx="21601113" cy="14400213"/>
   <p:notesSz cx="9144000" cy="6858000"/>
@@ -4420,6 +4431,654 @@
 </p:sld>
 </file>
 
+<file path=ppt/slides/slide10.xml><?xml version="1.0" encoding="utf-8"?>
+<p:sld xmlns:a="http://schemas.openxmlformats.org/drawingml/2006/main" xmlns:r="http://schemas.openxmlformats.org/officeDocument/2006/relationships" xmlns:p="http://schemas.openxmlformats.org/presentationml/2006/main">
+  <p:cSld>
+    <p:spTree>
+      <p:nvGrpSpPr>
+        <p:cNvPr id="1" name=""/>
+        <p:cNvGrpSpPr/>
+        <p:nvPr/>
+      </p:nvGrpSpPr>
+      <p:grpSpPr>
+        <a:xfrm>
+          <a:off x="0" y="0"/>
+          <a:ext cx="0" cy="0"/>
+          <a:chOff x="0" y="0"/>
+          <a:chExt cx="0" cy="0"/>
+        </a:xfrm>
+      </p:grpSpPr>
+      <p:pic>
+        <p:nvPicPr>
+          <p:cNvPr id="3" name="Picture 2" descr="The image depicts a computer interface with a user interface element for a map question, allowing operators to select and mark multiple areas.&#10;&#10;AI-generated content may be incorrect.">
+            <a:extLst>
+              <a:ext uri="{FF2B5EF4-FFF2-40B4-BE49-F238E27FC236}">
+                <a16:creationId xmlns:a16="http://schemas.microsoft.com/office/drawing/2014/main" id="{3BE9186B-B819-2672-5B1C-701148CF8D18}"/>
+              </a:ext>
+            </a:extLst>
+          </p:cNvPr>
+          <p:cNvPicPr>
+            <a:picLocks noChangeAspect="1"/>
+          </p:cNvPicPr>
+          <p:nvPr/>
+        </p:nvPicPr>
+        <p:blipFill>
+          <a:blip r:embed="rId2"/>
+          <a:stretch>
+            <a:fillRect/>
+          </a:stretch>
+        </p:blipFill>
+        <p:spPr>
+          <a:xfrm>
+            <a:off x="3898392" y="4968205"/>
+            <a:ext cx="6224721" cy="4485600"/>
+          </a:xfrm>
+          <a:prstGeom prst="rect">
+            <a:avLst/>
+          </a:prstGeom>
+        </p:spPr>
+      </p:pic>
+      <p:pic>
+        <p:nvPicPr>
+          <p:cNvPr id="5" name="Picture 4" descr="The image depicts a diagram with a figure outlined, indicating a map question where operators can select multiple areas, accounting for 75% of the content.&#10;&#10;AI-generated content may be incorrect.">
+            <a:extLst>
+              <a:ext uri="{FF2B5EF4-FFF2-40B4-BE49-F238E27FC236}">
+                <a16:creationId xmlns:a16="http://schemas.microsoft.com/office/drawing/2014/main" id="{F3E7042D-401D-270B-A50A-A1B745BD662D}"/>
+              </a:ext>
+            </a:extLst>
+          </p:cNvPr>
+          <p:cNvPicPr>
+            <a:picLocks noChangeAspect="1"/>
+          </p:cNvPicPr>
+          <p:nvPr/>
+        </p:nvPicPr>
+        <p:blipFill>
+          <a:blip r:embed="rId3"/>
+          <a:stretch>
+            <a:fillRect/>
+          </a:stretch>
+        </p:blipFill>
+        <p:spPr>
+          <a:xfrm>
+            <a:off x="10800556" y="4956005"/>
+            <a:ext cx="7176960" cy="4485600"/>
+          </a:xfrm>
+          <a:prstGeom prst="rect">
+            <a:avLst/>
+          </a:prstGeom>
+        </p:spPr>
+      </p:pic>
+      <p:sp>
+        <p:nvSpPr>
+          <p:cNvPr id="6" name="TextBox 5">
+            <a:extLst>
+              <a:ext uri="{FF2B5EF4-FFF2-40B4-BE49-F238E27FC236}">
+                <a16:creationId xmlns:a16="http://schemas.microsoft.com/office/drawing/2014/main" id="{0F1B9B2E-FDF7-DDB0-91D8-FE49016BDA08}"/>
+              </a:ext>
+            </a:extLst>
+          </p:cNvPr>
+          <p:cNvSpPr txBox="1"/>
+          <p:nvPr/>
+        </p:nvSpPr>
+        <p:spPr>
+          <a:xfrm>
+            <a:off x="3898392" y="4371230"/>
+            <a:ext cx="3090590" cy="584775"/>
+          </a:xfrm>
+          <a:prstGeom prst="rect">
+            <a:avLst/>
+          </a:prstGeom>
+          <a:noFill/>
+        </p:spPr>
+        <p:txBody>
+          <a:bodyPr wrap="none" rtlCol="0">
+            <a:spAutoFit/>
+          </a:bodyPr>
+          <a:lstStyle/>
+          <a:p>
+            <a:r>
+              <a:rPr lang="en-US" sz="3200" dirty="0"/>
+              <a:t>Procedure Panel</a:t>
+            </a:r>
+            <a:endParaRPr lang="en-DK" sz="3200" dirty="0"/>
+          </a:p>
+        </p:txBody>
+      </p:sp>
+      <p:sp>
+        <p:nvSpPr>
+          <p:cNvPr id="7" name="TextBox 6">
+            <a:extLst>
+              <a:ext uri="{FF2B5EF4-FFF2-40B4-BE49-F238E27FC236}">
+                <a16:creationId xmlns:a16="http://schemas.microsoft.com/office/drawing/2014/main" id="{2D673EAF-B30B-8D4B-7832-81FEEAC83AA7}"/>
+              </a:ext>
+            </a:extLst>
+          </p:cNvPr>
+          <p:cNvSpPr txBox="1"/>
+          <p:nvPr/>
+        </p:nvSpPr>
+        <p:spPr>
+          <a:xfrm>
+            <a:off x="10800556" y="4371230"/>
+            <a:ext cx="3436903" cy="584775"/>
+          </a:xfrm>
+          <a:prstGeom prst="rect">
+            <a:avLst/>
+          </a:prstGeom>
+          <a:noFill/>
+        </p:spPr>
+        <p:txBody>
+          <a:bodyPr wrap="none" rtlCol="0">
+            <a:spAutoFit/>
+          </a:bodyPr>
+          <a:lstStyle/>
+          <a:p>
+            <a:r>
+              <a:rPr lang="en-US" sz="3200" dirty="0"/>
+              <a:t>Participant Screen</a:t>
+            </a:r>
+            <a:endParaRPr lang="en-DK" sz="3200" dirty="0"/>
+          </a:p>
+        </p:txBody>
+      </p:sp>
+    </p:spTree>
+    <p:extLst>
+      <p:ext uri="{BB962C8B-B14F-4D97-AF65-F5344CB8AC3E}">
+        <p14:creationId xmlns:p14="http://schemas.microsoft.com/office/powerpoint/2010/main" val="427304041"/>
+      </p:ext>
+    </p:extLst>
+  </p:cSld>
+  <p:clrMapOvr>
+    <a:masterClrMapping/>
+  </p:clrMapOvr>
+</p:sld>
+</file>
+
+<file path=ppt/slides/slide11.xml><?xml version="1.0" encoding="utf-8"?>
+<p:sld xmlns:a="http://schemas.openxmlformats.org/drawingml/2006/main" xmlns:r="http://schemas.openxmlformats.org/officeDocument/2006/relationships" xmlns:p="http://schemas.openxmlformats.org/presentationml/2006/main">
+  <p:cSld>
+    <p:spTree>
+      <p:nvGrpSpPr>
+        <p:cNvPr id="1" name=""/>
+        <p:cNvGrpSpPr/>
+        <p:nvPr/>
+      </p:nvGrpSpPr>
+      <p:grpSpPr>
+        <a:xfrm>
+          <a:off x="0" y="0"/>
+          <a:ext cx="0" cy="0"/>
+          <a:chOff x="0" y="0"/>
+          <a:chExt cx="0" cy="0"/>
+        </a:xfrm>
+      </p:grpSpPr>
+      <p:pic>
+        <p:nvPicPr>
+          <p:cNvPr id="3" name="Picture 2">
+            <a:extLst>
+              <a:ext uri="{FF2B5EF4-FFF2-40B4-BE49-F238E27FC236}">
+                <a16:creationId xmlns:a16="http://schemas.microsoft.com/office/drawing/2014/main" id="{B343B5C3-1F96-E5FC-2BE2-4E09B488741B}"/>
+              </a:ext>
+            </a:extLst>
+          </p:cNvPr>
+          <p:cNvPicPr>
+            <a:picLocks noChangeAspect="1"/>
+          </p:cNvPicPr>
+          <p:nvPr/>
+        </p:nvPicPr>
+        <p:blipFill>
+          <a:blip r:embed="rId2"/>
+          <a:stretch>
+            <a:fillRect/>
+          </a:stretch>
+        </p:blipFill>
+        <p:spPr>
+          <a:xfrm>
+            <a:off x="3898392" y="4958608"/>
+            <a:ext cx="6108250" cy="4485600"/>
+          </a:xfrm>
+          <a:prstGeom prst="rect">
+            <a:avLst/>
+          </a:prstGeom>
+        </p:spPr>
+      </p:pic>
+      <p:pic>
+        <p:nvPicPr>
+          <p:cNvPr id="5" name="Picture 4">
+            <a:extLst>
+              <a:ext uri="{FF2B5EF4-FFF2-40B4-BE49-F238E27FC236}">
+                <a16:creationId xmlns:a16="http://schemas.microsoft.com/office/drawing/2014/main" id="{E59BF876-609E-900A-74A9-9366FCAE9F0A}"/>
+              </a:ext>
+            </a:extLst>
+          </p:cNvPr>
+          <p:cNvPicPr>
+            <a:picLocks noChangeAspect="1"/>
+          </p:cNvPicPr>
+          <p:nvPr/>
+        </p:nvPicPr>
+        <p:blipFill>
+          <a:blip r:embed="rId3"/>
+          <a:stretch>
+            <a:fillRect/>
+          </a:stretch>
+        </p:blipFill>
+        <p:spPr>
+          <a:xfrm>
+            <a:off x="10800556" y="4958608"/>
+            <a:ext cx="7176960" cy="4485600"/>
+          </a:xfrm>
+          <a:prstGeom prst="rect">
+            <a:avLst/>
+          </a:prstGeom>
+        </p:spPr>
+      </p:pic>
+      <p:sp>
+        <p:nvSpPr>
+          <p:cNvPr id="6" name="TextBox 5">
+            <a:extLst>
+              <a:ext uri="{FF2B5EF4-FFF2-40B4-BE49-F238E27FC236}">
+                <a16:creationId xmlns:a16="http://schemas.microsoft.com/office/drawing/2014/main" id="{A70BC002-256D-7AD4-DD3B-B7292F0E0F9D}"/>
+              </a:ext>
+            </a:extLst>
+          </p:cNvPr>
+          <p:cNvSpPr txBox="1"/>
+          <p:nvPr/>
+        </p:nvSpPr>
+        <p:spPr>
+          <a:xfrm>
+            <a:off x="3898392" y="4371230"/>
+            <a:ext cx="3090590" cy="584775"/>
+          </a:xfrm>
+          <a:prstGeom prst="rect">
+            <a:avLst/>
+          </a:prstGeom>
+          <a:noFill/>
+        </p:spPr>
+        <p:txBody>
+          <a:bodyPr wrap="none" rtlCol="0">
+            <a:spAutoFit/>
+          </a:bodyPr>
+          <a:lstStyle/>
+          <a:p>
+            <a:r>
+              <a:rPr lang="en-US" sz="3200" dirty="0"/>
+              <a:t>Procedure Panel</a:t>
+            </a:r>
+            <a:endParaRPr lang="en-DK" sz="3200" dirty="0"/>
+          </a:p>
+        </p:txBody>
+      </p:sp>
+      <p:sp>
+        <p:nvSpPr>
+          <p:cNvPr id="7" name="TextBox 6">
+            <a:extLst>
+              <a:ext uri="{FF2B5EF4-FFF2-40B4-BE49-F238E27FC236}">
+                <a16:creationId xmlns:a16="http://schemas.microsoft.com/office/drawing/2014/main" id="{1B566FD1-A6EB-2C17-9759-2A8ACBEB96E6}"/>
+              </a:ext>
+            </a:extLst>
+          </p:cNvPr>
+          <p:cNvSpPr txBox="1"/>
+          <p:nvPr/>
+        </p:nvSpPr>
+        <p:spPr>
+          <a:xfrm>
+            <a:off x="10800556" y="4371230"/>
+            <a:ext cx="3436903" cy="584775"/>
+          </a:xfrm>
+          <a:prstGeom prst="rect">
+            <a:avLst/>
+          </a:prstGeom>
+          <a:noFill/>
+        </p:spPr>
+        <p:txBody>
+          <a:bodyPr wrap="none" rtlCol="0">
+            <a:spAutoFit/>
+          </a:bodyPr>
+          <a:lstStyle/>
+          <a:p>
+            <a:r>
+              <a:rPr lang="en-US" sz="3200" dirty="0"/>
+              <a:t>Participant Screen</a:t>
+            </a:r>
+            <a:endParaRPr lang="en-DK" sz="3200" dirty="0"/>
+          </a:p>
+        </p:txBody>
+      </p:sp>
+    </p:spTree>
+    <p:extLst>
+      <p:ext uri="{BB962C8B-B14F-4D97-AF65-F5344CB8AC3E}">
+        <p14:creationId xmlns:p14="http://schemas.microsoft.com/office/powerpoint/2010/main" val="1227359963"/>
+      </p:ext>
+    </p:extLst>
+  </p:cSld>
+  <p:clrMapOvr>
+    <a:masterClrMapping/>
+  </p:clrMapOvr>
+</p:sld>
+</file>
+
+<file path=ppt/slides/slide12.xml><?xml version="1.0" encoding="utf-8"?>
+<p:sld xmlns:a="http://schemas.openxmlformats.org/drawingml/2006/main" xmlns:r="http://schemas.openxmlformats.org/officeDocument/2006/relationships" xmlns:p="http://schemas.openxmlformats.org/presentationml/2006/main">
+  <p:cSld>
+    <p:spTree>
+      <p:nvGrpSpPr>
+        <p:cNvPr id="1" name=""/>
+        <p:cNvGrpSpPr/>
+        <p:nvPr/>
+      </p:nvGrpSpPr>
+      <p:grpSpPr>
+        <a:xfrm>
+          <a:off x="0" y="0"/>
+          <a:ext cx="0" cy="0"/>
+          <a:chOff x="0" y="0"/>
+          <a:chExt cx="0" cy="0"/>
+        </a:xfrm>
+      </p:grpSpPr>
+      <p:pic>
+        <p:nvPicPr>
+          <p:cNvPr id="3" name="Picture 2" descr="The image displays a Visual Analog Rating Question interface, with a slider ranging from 'No Sensation' to 'Maximal Sensation,' and includes buttons for 'Back' and 'Next'.&#10;&#10;AI-generated content may be incorrect.">
+            <a:extLst>
+              <a:ext uri="{FF2B5EF4-FFF2-40B4-BE49-F238E27FC236}">
+                <a16:creationId xmlns:a16="http://schemas.microsoft.com/office/drawing/2014/main" id="{6DF75D7A-670D-431D-59AB-CB954E02CA14}"/>
+              </a:ext>
+            </a:extLst>
+          </p:cNvPr>
+          <p:cNvPicPr>
+            <a:picLocks noChangeAspect="1"/>
+          </p:cNvPicPr>
+          <p:nvPr/>
+        </p:nvPicPr>
+        <p:blipFill>
+          <a:blip r:embed="rId2"/>
+          <a:stretch>
+            <a:fillRect/>
+          </a:stretch>
+        </p:blipFill>
+        <p:spPr>
+          <a:xfrm>
+            <a:off x="3898392" y="4958608"/>
+            <a:ext cx="6117576" cy="4485600"/>
+          </a:xfrm>
+          <a:prstGeom prst="rect">
+            <a:avLst/>
+          </a:prstGeom>
+        </p:spPr>
+      </p:pic>
+      <p:pic>
+        <p:nvPicPr>
+          <p:cNvPr id="5" name="Picture 4" descr="No Sensation&#10;&#10;AI-generated content may be incorrect.">
+            <a:extLst>
+              <a:ext uri="{FF2B5EF4-FFF2-40B4-BE49-F238E27FC236}">
+                <a16:creationId xmlns:a16="http://schemas.microsoft.com/office/drawing/2014/main" id="{03FB08DC-B3CC-F83A-CE53-6FC45E6D12C3}"/>
+              </a:ext>
+            </a:extLst>
+          </p:cNvPr>
+          <p:cNvPicPr>
+            <a:picLocks noChangeAspect="1"/>
+          </p:cNvPicPr>
+          <p:nvPr/>
+        </p:nvPicPr>
+        <p:blipFill>
+          <a:blip r:embed="rId3"/>
+          <a:stretch>
+            <a:fillRect/>
+          </a:stretch>
+        </p:blipFill>
+        <p:spPr>
+          <a:xfrm>
+            <a:off x="10800556" y="4956005"/>
+            <a:ext cx="7176960" cy="4485600"/>
+          </a:xfrm>
+          <a:prstGeom prst="rect">
+            <a:avLst/>
+          </a:prstGeom>
+        </p:spPr>
+      </p:pic>
+      <p:sp>
+        <p:nvSpPr>
+          <p:cNvPr id="6" name="TextBox 5">
+            <a:extLst>
+              <a:ext uri="{FF2B5EF4-FFF2-40B4-BE49-F238E27FC236}">
+                <a16:creationId xmlns:a16="http://schemas.microsoft.com/office/drawing/2014/main" id="{C464EAD3-D37A-0E36-BF3F-CC177E281293}"/>
+              </a:ext>
+            </a:extLst>
+          </p:cNvPr>
+          <p:cNvSpPr txBox="1"/>
+          <p:nvPr/>
+        </p:nvSpPr>
+        <p:spPr>
+          <a:xfrm>
+            <a:off x="3898392" y="4371230"/>
+            <a:ext cx="3090590" cy="584775"/>
+          </a:xfrm>
+          <a:prstGeom prst="rect">
+            <a:avLst/>
+          </a:prstGeom>
+          <a:noFill/>
+        </p:spPr>
+        <p:txBody>
+          <a:bodyPr wrap="none" rtlCol="0">
+            <a:spAutoFit/>
+          </a:bodyPr>
+          <a:lstStyle/>
+          <a:p>
+            <a:r>
+              <a:rPr lang="en-US" sz="3200" dirty="0"/>
+              <a:t>Procedure Panel</a:t>
+            </a:r>
+            <a:endParaRPr lang="en-DK" sz="3200" dirty="0"/>
+          </a:p>
+        </p:txBody>
+      </p:sp>
+      <p:sp>
+        <p:nvSpPr>
+          <p:cNvPr id="7" name="TextBox 6">
+            <a:extLst>
+              <a:ext uri="{FF2B5EF4-FFF2-40B4-BE49-F238E27FC236}">
+                <a16:creationId xmlns:a16="http://schemas.microsoft.com/office/drawing/2014/main" id="{AB948D1E-43DE-9698-D00E-0D5742A7B7DD}"/>
+              </a:ext>
+            </a:extLst>
+          </p:cNvPr>
+          <p:cNvSpPr txBox="1"/>
+          <p:nvPr/>
+        </p:nvSpPr>
+        <p:spPr>
+          <a:xfrm>
+            <a:off x="10800556" y="4371230"/>
+            <a:ext cx="3436903" cy="584775"/>
+          </a:xfrm>
+          <a:prstGeom prst="rect">
+            <a:avLst/>
+          </a:prstGeom>
+          <a:noFill/>
+        </p:spPr>
+        <p:txBody>
+          <a:bodyPr wrap="none" rtlCol="0">
+            <a:spAutoFit/>
+          </a:bodyPr>
+          <a:lstStyle/>
+          <a:p>
+            <a:r>
+              <a:rPr lang="en-US" sz="3200" dirty="0"/>
+              <a:t>Participant Screen</a:t>
+            </a:r>
+            <a:endParaRPr lang="en-DK" sz="3200" dirty="0"/>
+          </a:p>
+        </p:txBody>
+      </p:sp>
+    </p:spTree>
+    <p:extLst>
+      <p:ext uri="{BB962C8B-B14F-4D97-AF65-F5344CB8AC3E}">
+        <p14:creationId xmlns:p14="http://schemas.microsoft.com/office/powerpoint/2010/main" val="2625725855"/>
+      </p:ext>
+    </p:extLst>
+  </p:cSld>
+  <p:clrMapOvr>
+    <a:masterClrMapping/>
+  </p:clrMapOvr>
+</p:sld>
+</file>
+
+<file path=ppt/slides/slide13.xml><?xml version="1.0" encoding="utf-8"?>
+<p:sld xmlns:a="http://schemas.openxmlformats.org/drawingml/2006/main" xmlns:r="http://schemas.openxmlformats.org/officeDocument/2006/relationships" xmlns:p="http://schemas.openxmlformats.org/presentationml/2006/main">
+  <p:cSld>
+    <p:spTree>
+      <p:nvGrpSpPr>
+        <p:cNvPr id="1" name=""/>
+        <p:cNvGrpSpPr/>
+        <p:nvPr/>
+      </p:nvGrpSpPr>
+      <p:grpSpPr>
+        <a:xfrm>
+          <a:off x="0" y="0"/>
+          <a:ext cx="0" cy="0"/>
+          <a:chOff x="0" y="0"/>
+          <a:chExt cx="0" cy="0"/>
+        </a:xfrm>
+      </p:grpSpPr>
+      <p:pic>
+        <p:nvPicPr>
+          <p:cNvPr id="3" name="Picture 2">
+            <a:extLst>
+              <a:ext uri="{FF2B5EF4-FFF2-40B4-BE49-F238E27FC236}">
+                <a16:creationId xmlns:a16="http://schemas.microsoft.com/office/drawing/2014/main" id="{ACED1A91-3F3D-79E0-0BD9-A75B20A56F5D}"/>
+              </a:ext>
+            </a:extLst>
+          </p:cNvPr>
+          <p:cNvPicPr>
+            <a:picLocks noChangeAspect="1"/>
+          </p:cNvPicPr>
+          <p:nvPr/>
+        </p:nvPicPr>
+        <p:blipFill>
+          <a:blip r:embed="rId2"/>
+          <a:stretch>
+            <a:fillRect/>
+          </a:stretch>
+        </p:blipFill>
+        <p:spPr>
+          <a:xfrm>
+            <a:off x="3898392" y="5178220"/>
+            <a:ext cx="7945388" cy="4485600"/>
+          </a:xfrm>
+          <a:prstGeom prst="rect">
+            <a:avLst/>
+          </a:prstGeom>
+        </p:spPr>
+      </p:pic>
+      <p:pic>
+        <p:nvPicPr>
+          <p:cNvPr id="5" name="Picture 4">
+            <a:extLst>
+              <a:ext uri="{FF2B5EF4-FFF2-40B4-BE49-F238E27FC236}">
+                <a16:creationId xmlns:a16="http://schemas.microsoft.com/office/drawing/2014/main" id="{6155C616-0B17-F4E6-908A-E383CA7B6F0D}"/>
+              </a:ext>
+            </a:extLst>
+          </p:cNvPr>
+          <p:cNvPicPr>
+            <a:picLocks noChangeAspect="1"/>
+          </p:cNvPicPr>
+          <p:nvPr/>
+        </p:nvPicPr>
+        <p:blipFill>
+          <a:blip r:embed="rId3"/>
+          <a:stretch>
+            <a:fillRect/>
+          </a:stretch>
+        </p:blipFill>
+        <p:spPr>
+          <a:xfrm>
+            <a:off x="12265917" y="5178220"/>
+            <a:ext cx="7176960" cy="4485600"/>
+          </a:xfrm>
+          <a:prstGeom prst="rect">
+            <a:avLst/>
+          </a:prstGeom>
+        </p:spPr>
+      </p:pic>
+      <p:sp>
+        <p:nvSpPr>
+          <p:cNvPr id="6" name="TextBox 5">
+            <a:extLst>
+              <a:ext uri="{FF2B5EF4-FFF2-40B4-BE49-F238E27FC236}">
+                <a16:creationId xmlns:a16="http://schemas.microsoft.com/office/drawing/2014/main" id="{6527014E-DC6E-92B0-4E3D-C9FD9B020855}"/>
+              </a:ext>
+            </a:extLst>
+          </p:cNvPr>
+          <p:cNvSpPr txBox="1"/>
+          <p:nvPr/>
+        </p:nvSpPr>
+        <p:spPr>
+          <a:xfrm>
+            <a:off x="3898392" y="4579050"/>
+            <a:ext cx="3090590" cy="584775"/>
+          </a:xfrm>
+          <a:prstGeom prst="rect">
+            <a:avLst/>
+          </a:prstGeom>
+          <a:noFill/>
+        </p:spPr>
+        <p:txBody>
+          <a:bodyPr wrap="none" rtlCol="0">
+            <a:spAutoFit/>
+          </a:bodyPr>
+          <a:lstStyle/>
+          <a:p>
+            <a:r>
+              <a:rPr lang="en-US" sz="3200" dirty="0"/>
+              <a:t>Procedure Panel</a:t>
+            </a:r>
+            <a:endParaRPr lang="en-DK" sz="3200" dirty="0"/>
+          </a:p>
+        </p:txBody>
+      </p:sp>
+      <p:sp>
+        <p:nvSpPr>
+          <p:cNvPr id="7" name="TextBox 6">
+            <a:extLst>
+              <a:ext uri="{FF2B5EF4-FFF2-40B4-BE49-F238E27FC236}">
+                <a16:creationId xmlns:a16="http://schemas.microsoft.com/office/drawing/2014/main" id="{A04EE31F-79DC-73AD-8B26-36454E71C176}"/>
+              </a:ext>
+            </a:extLst>
+          </p:cNvPr>
+          <p:cNvSpPr txBox="1"/>
+          <p:nvPr/>
+        </p:nvSpPr>
+        <p:spPr>
+          <a:xfrm>
+            <a:off x="12265917" y="4579049"/>
+            <a:ext cx="3436903" cy="584775"/>
+          </a:xfrm>
+          <a:prstGeom prst="rect">
+            <a:avLst/>
+          </a:prstGeom>
+          <a:noFill/>
+        </p:spPr>
+        <p:txBody>
+          <a:bodyPr wrap="none" rtlCol="0">
+            <a:spAutoFit/>
+          </a:bodyPr>
+          <a:lstStyle/>
+          <a:p>
+            <a:r>
+              <a:rPr lang="en-US" sz="3200" dirty="0"/>
+              <a:t>Participant Screen</a:t>
+            </a:r>
+            <a:endParaRPr lang="en-DK" sz="3200" dirty="0"/>
+          </a:p>
+        </p:txBody>
+      </p:sp>
+    </p:spTree>
+    <p:extLst>
+      <p:ext uri="{BB962C8B-B14F-4D97-AF65-F5344CB8AC3E}">
+        <p14:creationId xmlns:p14="http://schemas.microsoft.com/office/powerpoint/2010/main" val="3399761481"/>
+      </p:ext>
+    </p:extLst>
+  </p:cSld>
+  <p:clrMapOvr>
+    <a:masterClrMapping/>
+  </p:clrMapOvr>
+</p:sld>
+</file>
+
 <file path=ppt/slides/slide2.xml><?xml version="1.0" encoding="utf-8"?>
 <p:sld xmlns:a="http://schemas.openxmlformats.org/drawingml/2006/main" xmlns:r="http://schemas.openxmlformats.org/officeDocument/2006/relationships" xmlns:p="http://schemas.openxmlformats.org/presentationml/2006/main">
   <p:cSld>
@@ -4749,6 +5408,1140 @@
     <p:extLst>
       <p:ext uri="{BB962C8B-B14F-4D97-AF65-F5344CB8AC3E}">
         <p14:creationId xmlns:p14="http://schemas.microsoft.com/office/powerpoint/2010/main" val="2435479675"/>
+      </p:ext>
+    </p:extLst>
+  </p:cSld>
+  <p:clrMapOvr>
+    <a:masterClrMapping/>
+  </p:clrMapOvr>
+</p:sld>
+</file>
+
+<file path=ppt/slides/slide3.xml><?xml version="1.0" encoding="utf-8"?>
+<p:sld xmlns:a="http://schemas.openxmlformats.org/drawingml/2006/main" xmlns:r="http://schemas.openxmlformats.org/officeDocument/2006/relationships" xmlns:p="http://schemas.openxmlformats.org/presentationml/2006/main">
+  <p:cSld>
+    <p:spTree>
+      <p:nvGrpSpPr>
+        <p:cNvPr id="1" name=""/>
+        <p:cNvGrpSpPr/>
+        <p:nvPr/>
+      </p:nvGrpSpPr>
+      <p:grpSpPr>
+        <a:xfrm>
+          <a:off x="0" y="0"/>
+          <a:ext cx="0" cy="0"/>
+          <a:chOff x="0" y="0"/>
+          <a:chExt cx="0" cy="0"/>
+        </a:xfrm>
+      </p:grpSpPr>
+      <p:pic>
+        <p:nvPicPr>
+          <p:cNvPr id="3" name="Picture 2" descr="The image shows a user interface with a question prompt asking for a yes or no answer, followed by options to continue or skip further questions.&#10;&#10;AI-generated content may be incorrect.">
+            <a:extLst>
+              <a:ext uri="{FF2B5EF4-FFF2-40B4-BE49-F238E27FC236}">
+                <a16:creationId xmlns:a16="http://schemas.microsoft.com/office/drawing/2014/main" id="{5ABC709A-2640-5D60-D30C-2997A78012F1}"/>
+              </a:ext>
+            </a:extLst>
+          </p:cNvPr>
+          <p:cNvPicPr>
+            <a:picLocks noChangeAspect="1"/>
+          </p:cNvPicPr>
+          <p:nvPr/>
+        </p:nvPicPr>
+        <p:blipFill>
+          <a:blip r:embed="rId2"/>
+          <a:stretch>
+            <a:fillRect/>
+          </a:stretch>
+        </p:blipFill>
+        <p:spPr>
+          <a:xfrm>
+            <a:off x="3898392" y="4956005"/>
+            <a:ext cx="6239746" cy="4486901"/>
+          </a:xfrm>
+          <a:prstGeom prst="rect">
+            <a:avLst/>
+          </a:prstGeom>
+        </p:spPr>
+      </p:pic>
+      <p:pic>
+        <p:nvPicPr>
+          <p:cNvPr id="5" name="Picture 4" descr="no&#10;&#10;AI-generated content may be incorrect.">
+            <a:extLst>
+              <a:ext uri="{FF2B5EF4-FFF2-40B4-BE49-F238E27FC236}">
+                <a16:creationId xmlns:a16="http://schemas.microsoft.com/office/drawing/2014/main" id="{B1118644-9CA1-D848-6E48-835EF0F784FA}"/>
+              </a:ext>
+            </a:extLst>
+          </p:cNvPr>
+          <p:cNvPicPr>
+            <a:picLocks noChangeAspect="1"/>
+          </p:cNvPicPr>
+          <p:nvPr/>
+        </p:nvPicPr>
+        <p:blipFill>
+          <a:blip r:embed="rId3"/>
+          <a:stretch>
+            <a:fillRect/>
+          </a:stretch>
+        </p:blipFill>
+        <p:spPr>
+          <a:xfrm>
+            <a:off x="10800556" y="4957306"/>
+            <a:ext cx="7176960" cy="4485600"/>
+          </a:xfrm>
+          <a:prstGeom prst="rect">
+            <a:avLst/>
+          </a:prstGeom>
+        </p:spPr>
+      </p:pic>
+      <p:sp>
+        <p:nvSpPr>
+          <p:cNvPr id="6" name="TextBox 5">
+            <a:extLst>
+              <a:ext uri="{FF2B5EF4-FFF2-40B4-BE49-F238E27FC236}">
+                <a16:creationId xmlns:a16="http://schemas.microsoft.com/office/drawing/2014/main" id="{2B6C49F4-B373-B265-DBEC-AE062627C5E7}"/>
+              </a:ext>
+            </a:extLst>
+          </p:cNvPr>
+          <p:cNvSpPr txBox="1"/>
+          <p:nvPr/>
+        </p:nvSpPr>
+        <p:spPr>
+          <a:xfrm>
+            <a:off x="3898392" y="4371230"/>
+            <a:ext cx="3090590" cy="584775"/>
+          </a:xfrm>
+          <a:prstGeom prst="rect">
+            <a:avLst/>
+          </a:prstGeom>
+          <a:noFill/>
+        </p:spPr>
+        <p:txBody>
+          <a:bodyPr wrap="none" rtlCol="0">
+            <a:spAutoFit/>
+          </a:bodyPr>
+          <a:lstStyle/>
+          <a:p>
+            <a:r>
+              <a:rPr lang="en-US" sz="3200" dirty="0"/>
+              <a:t>Procedure Panel</a:t>
+            </a:r>
+            <a:endParaRPr lang="en-DK" sz="3200" dirty="0"/>
+          </a:p>
+        </p:txBody>
+      </p:sp>
+      <p:sp>
+        <p:nvSpPr>
+          <p:cNvPr id="7" name="TextBox 6">
+            <a:extLst>
+              <a:ext uri="{FF2B5EF4-FFF2-40B4-BE49-F238E27FC236}">
+                <a16:creationId xmlns:a16="http://schemas.microsoft.com/office/drawing/2014/main" id="{E27971D5-2474-DF30-4FCD-8055CFF713A9}"/>
+              </a:ext>
+            </a:extLst>
+          </p:cNvPr>
+          <p:cNvSpPr txBox="1"/>
+          <p:nvPr/>
+        </p:nvSpPr>
+        <p:spPr>
+          <a:xfrm>
+            <a:off x="10800556" y="4371230"/>
+            <a:ext cx="3436903" cy="584775"/>
+          </a:xfrm>
+          <a:prstGeom prst="rect">
+            <a:avLst/>
+          </a:prstGeom>
+          <a:noFill/>
+        </p:spPr>
+        <p:txBody>
+          <a:bodyPr wrap="none" rtlCol="0">
+            <a:spAutoFit/>
+          </a:bodyPr>
+          <a:lstStyle/>
+          <a:p>
+            <a:r>
+              <a:rPr lang="en-US" sz="3200" dirty="0"/>
+              <a:t>Participant Screen</a:t>
+            </a:r>
+            <a:endParaRPr lang="en-DK" sz="3200" dirty="0"/>
+          </a:p>
+        </p:txBody>
+      </p:sp>
+    </p:spTree>
+    <p:extLst>
+      <p:ext uri="{BB962C8B-B14F-4D97-AF65-F5344CB8AC3E}">
+        <p14:creationId xmlns:p14="http://schemas.microsoft.com/office/powerpoint/2010/main" val="3177600871"/>
+      </p:ext>
+    </p:extLst>
+  </p:cSld>
+  <p:clrMapOvr>
+    <a:masterClrMapping/>
+  </p:clrMapOvr>
+</p:sld>
+</file>
+
+<file path=ppt/slides/slide4.xml><?xml version="1.0" encoding="utf-8"?>
+<p:sld xmlns:a="http://schemas.openxmlformats.org/drawingml/2006/main" xmlns:r="http://schemas.openxmlformats.org/officeDocument/2006/relationships" xmlns:p="http://schemas.openxmlformats.org/presentationml/2006/main">
+  <p:cSld>
+    <p:spTree>
+      <p:nvGrpSpPr>
+        <p:cNvPr id="1" name=""/>
+        <p:cNvGrpSpPr/>
+        <p:nvPr/>
+      </p:nvGrpSpPr>
+      <p:grpSpPr>
+        <a:xfrm>
+          <a:off x="0" y="0"/>
+          <a:ext cx="0" cy="0"/>
+          <a:chOff x="0" y="0"/>
+          <a:chExt cx="0" cy="0"/>
+        </a:xfrm>
+      </p:grpSpPr>
+      <p:pic>
+        <p:nvPicPr>
+          <p:cNvPr id="3" name="Picture 2" descr="The image shows a text input field on a webpage with a prompt to answer a question, a percentage (16%), and a space for entering the answer, which is followed by a numeric input (23/256).&#10;&#10;AI-generated content may be incorrect.">
+            <a:extLst>
+              <a:ext uri="{FF2B5EF4-FFF2-40B4-BE49-F238E27FC236}">
+                <a16:creationId xmlns:a16="http://schemas.microsoft.com/office/drawing/2014/main" id="{8668E415-BB48-E918-CA23-B49CE3C4288C}"/>
+              </a:ext>
+            </a:extLst>
+          </p:cNvPr>
+          <p:cNvPicPr>
+            <a:picLocks noChangeAspect="1"/>
+          </p:cNvPicPr>
+          <p:nvPr/>
+        </p:nvPicPr>
+        <p:blipFill>
+          <a:blip r:embed="rId2"/>
+          <a:stretch>
+            <a:fillRect/>
+          </a:stretch>
+        </p:blipFill>
+        <p:spPr>
+          <a:xfrm>
+            <a:off x="3898392" y="4958608"/>
+            <a:ext cx="6136227" cy="4485600"/>
+          </a:xfrm>
+          <a:prstGeom prst="rect">
+            <a:avLst/>
+          </a:prstGeom>
+        </p:spPr>
+      </p:pic>
+      <p:pic>
+        <p:nvPicPr>
+          <p:cNvPr id="5" name="Picture 4" descr="16%&#10;&#10;AI-generated content may be incorrect.">
+            <a:extLst>
+              <a:ext uri="{FF2B5EF4-FFF2-40B4-BE49-F238E27FC236}">
+                <a16:creationId xmlns:a16="http://schemas.microsoft.com/office/drawing/2014/main" id="{56BE893F-35BB-380D-A846-B3554E684C24}"/>
+              </a:ext>
+            </a:extLst>
+          </p:cNvPr>
+          <p:cNvPicPr>
+            <a:picLocks noChangeAspect="1"/>
+          </p:cNvPicPr>
+          <p:nvPr/>
+        </p:nvPicPr>
+        <p:blipFill>
+          <a:blip r:embed="rId3"/>
+          <a:stretch>
+            <a:fillRect/>
+          </a:stretch>
+        </p:blipFill>
+        <p:spPr>
+          <a:xfrm>
+            <a:off x="10800556" y="4958608"/>
+            <a:ext cx="7176960" cy="4485600"/>
+          </a:xfrm>
+          <a:prstGeom prst="rect">
+            <a:avLst/>
+          </a:prstGeom>
+        </p:spPr>
+      </p:pic>
+      <p:sp>
+        <p:nvSpPr>
+          <p:cNvPr id="6" name="TextBox 5">
+            <a:extLst>
+              <a:ext uri="{FF2B5EF4-FFF2-40B4-BE49-F238E27FC236}">
+                <a16:creationId xmlns:a16="http://schemas.microsoft.com/office/drawing/2014/main" id="{8AC76001-B094-D4EC-CA2B-F468BC24C422}"/>
+              </a:ext>
+            </a:extLst>
+          </p:cNvPr>
+          <p:cNvSpPr txBox="1"/>
+          <p:nvPr/>
+        </p:nvSpPr>
+        <p:spPr>
+          <a:xfrm>
+            <a:off x="3898392" y="4371230"/>
+            <a:ext cx="3090590" cy="584775"/>
+          </a:xfrm>
+          <a:prstGeom prst="rect">
+            <a:avLst/>
+          </a:prstGeom>
+          <a:noFill/>
+        </p:spPr>
+        <p:txBody>
+          <a:bodyPr wrap="none" rtlCol="0">
+            <a:spAutoFit/>
+          </a:bodyPr>
+          <a:lstStyle/>
+          <a:p>
+            <a:r>
+              <a:rPr lang="en-US" sz="3200" dirty="0"/>
+              <a:t>Procedure Panel</a:t>
+            </a:r>
+            <a:endParaRPr lang="en-DK" sz="3200" dirty="0"/>
+          </a:p>
+        </p:txBody>
+      </p:sp>
+      <p:sp>
+        <p:nvSpPr>
+          <p:cNvPr id="7" name="TextBox 6">
+            <a:extLst>
+              <a:ext uri="{FF2B5EF4-FFF2-40B4-BE49-F238E27FC236}">
+                <a16:creationId xmlns:a16="http://schemas.microsoft.com/office/drawing/2014/main" id="{01051BB0-F3A7-7616-2775-E0EF2D7DAFF8}"/>
+              </a:ext>
+            </a:extLst>
+          </p:cNvPr>
+          <p:cNvSpPr txBox="1"/>
+          <p:nvPr/>
+        </p:nvSpPr>
+        <p:spPr>
+          <a:xfrm>
+            <a:off x="10800556" y="4371230"/>
+            <a:ext cx="3436903" cy="584775"/>
+          </a:xfrm>
+          <a:prstGeom prst="rect">
+            <a:avLst/>
+          </a:prstGeom>
+          <a:noFill/>
+        </p:spPr>
+        <p:txBody>
+          <a:bodyPr wrap="none" rtlCol="0">
+            <a:spAutoFit/>
+          </a:bodyPr>
+          <a:lstStyle/>
+          <a:p>
+            <a:r>
+              <a:rPr lang="en-US" sz="3200" dirty="0"/>
+              <a:t>Participant Screen</a:t>
+            </a:r>
+            <a:endParaRPr lang="en-DK" sz="3200" dirty="0"/>
+          </a:p>
+        </p:txBody>
+      </p:sp>
+    </p:spTree>
+    <p:extLst>
+      <p:ext uri="{BB962C8B-B14F-4D97-AF65-F5344CB8AC3E}">
+        <p14:creationId xmlns:p14="http://schemas.microsoft.com/office/powerpoint/2010/main" val="3502848593"/>
+      </p:ext>
+    </p:extLst>
+  </p:cSld>
+  <p:clrMapOvr>
+    <a:masterClrMapping/>
+  </p:clrMapOvr>
+</p:sld>
+</file>
+
+<file path=ppt/slides/slide5.xml><?xml version="1.0" encoding="utf-8"?>
+<p:sld xmlns:a="http://schemas.openxmlformats.org/drawingml/2006/main" xmlns:r="http://schemas.openxmlformats.org/officeDocument/2006/relationships" xmlns:p="http://schemas.openxmlformats.org/presentationml/2006/main">
+  <p:cSld>
+    <p:spTree>
+      <p:nvGrpSpPr>
+        <p:cNvPr id="1" name=""/>
+        <p:cNvGrpSpPr/>
+        <p:nvPr/>
+      </p:nvGrpSpPr>
+      <p:grpSpPr>
+        <a:xfrm>
+          <a:off x="0" y="0"/>
+          <a:ext cx="0" cy="0"/>
+          <a:chOff x="0" y="0"/>
+          <a:chExt cx="0" cy="0"/>
+        </a:xfrm>
+      </p:grpSpPr>
+      <p:pic>
+        <p:nvPicPr>
+          <p:cNvPr id="3" name="Picture 2" descr="The image displays a fill-in-the-blank style quiz question asking for a numeric answer, specifically number 42.&#10;&#10;AI-generated content may be incorrect.">
+            <a:extLst>
+              <a:ext uri="{FF2B5EF4-FFF2-40B4-BE49-F238E27FC236}">
+                <a16:creationId xmlns:a16="http://schemas.microsoft.com/office/drawing/2014/main" id="{086A2697-FCA9-B1B3-6C16-CF03940D4D2F}"/>
+              </a:ext>
+            </a:extLst>
+          </p:cNvPr>
+          <p:cNvPicPr>
+            <a:picLocks noChangeAspect="1"/>
+          </p:cNvPicPr>
+          <p:nvPr/>
+        </p:nvPicPr>
+        <p:blipFill>
+          <a:blip r:embed="rId2"/>
+          <a:stretch>
+            <a:fillRect/>
+          </a:stretch>
+        </p:blipFill>
+        <p:spPr>
+          <a:xfrm>
+            <a:off x="3898392" y="4956005"/>
+            <a:ext cx="6279840" cy="4485600"/>
+          </a:xfrm>
+          <a:prstGeom prst="rect">
+            <a:avLst/>
+          </a:prstGeom>
+        </p:spPr>
+      </p:pic>
+      <p:pic>
+        <p:nvPicPr>
+          <p:cNvPr id="5" name="Picture 4" descr="42.&#10;&#10;AI-generated content may be incorrect.">
+            <a:extLst>
+              <a:ext uri="{FF2B5EF4-FFF2-40B4-BE49-F238E27FC236}">
+                <a16:creationId xmlns:a16="http://schemas.microsoft.com/office/drawing/2014/main" id="{CD59B736-C129-6230-4D2E-98D0B7501160}"/>
+              </a:ext>
+            </a:extLst>
+          </p:cNvPr>
+          <p:cNvPicPr>
+            <a:picLocks noChangeAspect="1"/>
+          </p:cNvPicPr>
+          <p:nvPr/>
+        </p:nvPicPr>
+        <p:blipFill>
+          <a:blip r:embed="rId3"/>
+          <a:stretch>
+            <a:fillRect/>
+          </a:stretch>
+        </p:blipFill>
+        <p:spPr>
+          <a:xfrm>
+            <a:off x="10800556" y="4956005"/>
+            <a:ext cx="7176960" cy="4485600"/>
+          </a:xfrm>
+          <a:prstGeom prst="rect">
+            <a:avLst/>
+          </a:prstGeom>
+        </p:spPr>
+      </p:pic>
+      <p:sp>
+        <p:nvSpPr>
+          <p:cNvPr id="6" name="TextBox 5">
+            <a:extLst>
+              <a:ext uri="{FF2B5EF4-FFF2-40B4-BE49-F238E27FC236}">
+                <a16:creationId xmlns:a16="http://schemas.microsoft.com/office/drawing/2014/main" id="{88AB72C9-B3B7-C62D-5CB9-3649F503BC9F}"/>
+              </a:ext>
+            </a:extLst>
+          </p:cNvPr>
+          <p:cNvSpPr txBox="1"/>
+          <p:nvPr/>
+        </p:nvSpPr>
+        <p:spPr>
+          <a:xfrm>
+            <a:off x="3898392" y="4371230"/>
+            <a:ext cx="3090590" cy="584775"/>
+          </a:xfrm>
+          <a:prstGeom prst="rect">
+            <a:avLst/>
+          </a:prstGeom>
+          <a:noFill/>
+        </p:spPr>
+        <p:txBody>
+          <a:bodyPr wrap="none" rtlCol="0">
+            <a:spAutoFit/>
+          </a:bodyPr>
+          <a:lstStyle/>
+          <a:p>
+            <a:r>
+              <a:rPr lang="en-US" sz="3200" dirty="0"/>
+              <a:t>Procedure Panel</a:t>
+            </a:r>
+            <a:endParaRPr lang="en-DK" sz="3200" dirty="0"/>
+          </a:p>
+        </p:txBody>
+      </p:sp>
+      <p:sp>
+        <p:nvSpPr>
+          <p:cNvPr id="7" name="TextBox 6">
+            <a:extLst>
+              <a:ext uri="{FF2B5EF4-FFF2-40B4-BE49-F238E27FC236}">
+                <a16:creationId xmlns:a16="http://schemas.microsoft.com/office/drawing/2014/main" id="{7AECB6E8-994D-3E6C-FC7D-4467E7F45EDC}"/>
+              </a:ext>
+            </a:extLst>
+          </p:cNvPr>
+          <p:cNvSpPr txBox="1"/>
+          <p:nvPr/>
+        </p:nvSpPr>
+        <p:spPr>
+          <a:xfrm>
+            <a:off x="10800556" y="4371230"/>
+            <a:ext cx="3436903" cy="584775"/>
+          </a:xfrm>
+          <a:prstGeom prst="rect">
+            <a:avLst/>
+          </a:prstGeom>
+          <a:noFill/>
+        </p:spPr>
+        <p:txBody>
+          <a:bodyPr wrap="none" rtlCol="0">
+            <a:spAutoFit/>
+          </a:bodyPr>
+          <a:lstStyle/>
+          <a:p>
+            <a:r>
+              <a:rPr lang="en-US" sz="3200" dirty="0"/>
+              <a:t>Participant Screen</a:t>
+            </a:r>
+            <a:endParaRPr lang="en-DK" sz="3200" dirty="0"/>
+          </a:p>
+        </p:txBody>
+      </p:sp>
+    </p:spTree>
+    <p:extLst>
+      <p:ext uri="{BB962C8B-B14F-4D97-AF65-F5344CB8AC3E}">
+        <p14:creationId xmlns:p14="http://schemas.microsoft.com/office/powerpoint/2010/main" val="996517154"/>
+      </p:ext>
+    </p:extLst>
+  </p:cSld>
+  <p:clrMapOvr>
+    <a:masterClrMapping/>
+  </p:clrMapOvr>
+</p:sld>
+</file>
+
+<file path=ppt/slides/slide6.xml><?xml version="1.0" encoding="utf-8"?>
+<p:sld xmlns:a="http://schemas.openxmlformats.org/drawingml/2006/main" xmlns:r="http://schemas.openxmlformats.org/officeDocument/2006/relationships" xmlns:p="http://schemas.openxmlformats.org/presentationml/2006/main">
+  <p:cSld>
+    <p:spTree>
+      <p:nvGrpSpPr>
+        <p:cNvPr id="1" name=""/>
+        <p:cNvGrpSpPr/>
+        <p:nvPr/>
+      </p:nvGrpSpPr>
+      <p:grpSpPr>
+        <a:xfrm>
+          <a:off x="0" y="0"/>
+          <a:ext cx="0" cy="0"/>
+          <a:chOff x="0" y="0"/>
+          <a:chExt cx="0" cy="0"/>
+        </a:xfrm>
+      </p:grpSpPr>
+      <p:pic>
+        <p:nvPicPr>
+          <p:cNvPr id="3" name="Picture 2" descr="The image displays a Likert scale question with five possible answers (C1 to C5) for a survey or assessment.&#10;&#10;AI-generated content may be incorrect.">
+            <a:extLst>
+              <a:ext uri="{FF2B5EF4-FFF2-40B4-BE49-F238E27FC236}">
+                <a16:creationId xmlns:a16="http://schemas.microsoft.com/office/drawing/2014/main" id="{3AE8B0AF-90AF-7EF5-6A06-F38B33FE9ED7}"/>
+              </a:ext>
+            </a:extLst>
+          </p:cNvPr>
+          <p:cNvPicPr>
+            <a:picLocks noChangeAspect="1"/>
+          </p:cNvPicPr>
+          <p:nvPr/>
+        </p:nvPicPr>
+        <p:blipFill>
+          <a:blip r:embed="rId2"/>
+          <a:stretch>
+            <a:fillRect/>
+          </a:stretch>
+        </p:blipFill>
+        <p:spPr>
+          <a:xfrm>
+            <a:off x="3898392" y="4956005"/>
+            <a:ext cx="6154878" cy="4485600"/>
+          </a:xfrm>
+          <a:prstGeom prst="rect">
+            <a:avLst/>
+          </a:prstGeom>
+        </p:spPr>
+      </p:pic>
+      <p:pic>
+        <p:nvPicPr>
+          <p:cNvPr id="7" name="Picture 6" descr="The image shows a Likert scale question with five response options (C1 to C5) displayed on a black background.&#10;&#10;AI-generated content may be incorrect.">
+            <a:extLst>
+              <a:ext uri="{FF2B5EF4-FFF2-40B4-BE49-F238E27FC236}">
+                <a16:creationId xmlns:a16="http://schemas.microsoft.com/office/drawing/2014/main" id="{8BCFF6DF-1D03-621D-9756-71E2D74E1153}"/>
+              </a:ext>
+            </a:extLst>
+          </p:cNvPr>
+          <p:cNvPicPr>
+            <a:picLocks noChangeAspect="1"/>
+          </p:cNvPicPr>
+          <p:nvPr/>
+        </p:nvPicPr>
+        <p:blipFill>
+          <a:blip r:embed="rId3"/>
+          <a:stretch>
+            <a:fillRect/>
+          </a:stretch>
+        </p:blipFill>
+        <p:spPr>
+          <a:xfrm>
+            <a:off x="10800556" y="4956005"/>
+            <a:ext cx="7176960" cy="4485600"/>
+          </a:xfrm>
+          <a:prstGeom prst="rect">
+            <a:avLst/>
+          </a:prstGeom>
+        </p:spPr>
+      </p:pic>
+      <p:sp>
+        <p:nvSpPr>
+          <p:cNvPr id="8" name="TextBox 7">
+            <a:extLst>
+              <a:ext uri="{FF2B5EF4-FFF2-40B4-BE49-F238E27FC236}">
+                <a16:creationId xmlns:a16="http://schemas.microsoft.com/office/drawing/2014/main" id="{B0D798B8-E567-99C5-3096-E611B70F6450}"/>
+              </a:ext>
+            </a:extLst>
+          </p:cNvPr>
+          <p:cNvSpPr txBox="1"/>
+          <p:nvPr/>
+        </p:nvSpPr>
+        <p:spPr>
+          <a:xfrm>
+            <a:off x="3898392" y="4371230"/>
+            <a:ext cx="3090590" cy="584775"/>
+          </a:xfrm>
+          <a:prstGeom prst="rect">
+            <a:avLst/>
+          </a:prstGeom>
+          <a:noFill/>
+        </p:spPr>
+        <p:txBody>
+          <a:bodyPr wrap="none" rtlCol="0">
+            <a:spAutoFit/>
+          </a:bodyPr>
+          <a:lstStyle/>
+          <a:p>
+            <a:r>
+              <a:rPr lang="en-US" sz="3200" dirty="0"/>
+              <a:t>Procedure Panel</a:t>
+            </a:r>
+            <a:endParaRPr lang="en-DK" sz="3200" dirty="0"/>
+          </a:p>
+        </p:txBody>
+      </p:sp>
+      <p:sp>
+        <p:nvSpPr>
+          <p:cNvPr id="9" name="TextBox 8">
+            <a:extLst>
+              <a:ext uri="{FF2B5EF4-FFF2-40B4-BE49-F238E27FC236}">
+                <a16:creationId xmlns:a16="http://schemas.microsoft.com/office/drawing/2014/main" id="{26DD96B5-4AE7-61F0-CFC4-DC96C0AAB2EB}"/>
+              </a:ext>
+            </a:extLst>
+          </p:cNvPr>
+          <p:cNvSpPr txBox="1"/>
+          <p:nvPr/>
+        </p:nvSpPr>
+        <p:spPr>
+          <a:xfrm>
+            <a:off x="10800556" y="4371230"/>
+            <a:ext cx="3436903" cy="584775"/>
+          </a:xfrm>
+          <a:prstGeom prst="rect">
+            <a:avLst/>
+          </a:prstGeom>
+          <a:noFill/>
+        </p:spPr>
+        <p:txBody>
+          <a:bodyPr wrap="none" rtlCol="0">
+            <a:spAutoFit/>
+          </a:bodyPr>
+          <a:lstStyle/>
+          <a:p>
+            <a:r>
+              <a:rPr lang="en-US" sz="3200" dirty="0"/>
+              <a:t>Participant Screen</a:t>
+            </a:r>
+            <a:endParaRPr lang="en-DK" sz="3200" dirty="0"/>
+          </a:p>
+        </p:txBody>
+      </p:sp>
+    </p:spTree>
+    <p:extLst>
+      <p:ext uri="{BB962C8B-B14F-4D97-AF65-F5344CB8AC3E}">
+        <p14:creationId xmlns:p14="http://schemas.microsoft.com/office/powerpoint/2010/main" val="633041059"/>
+      </p:ext>
+    </p:extLst>
+  </p:cSld>
+  <p:clrMapOvr>
+    <a:masterClrMapping/>
+  </p:clrMapOvr>
+</p:sld>
+</file>
+
+<file path=ppt/slides/slide7.xml><?xml version="1.0" encoding="utf-8"?>
+<p:sld xmlns:a="http://schemas.openxmlformats.org/drawingml/2006/main" xmlns:r="http://schemas.openxmlformats.org/officeDocument/2006/relationships" xmlns:p="http://schemas.openxmlformats.org/presentationml/2006/main">
+  <p:cSld>
+    <p:spTree>
+      <p:nvGrpSpPr>
+        <p:cNvPr id="1" name=""/>
+        <p:cNvGrpSpPr/>
+        <p:nvPr/>
+      </p:nvGrpSpPr>
+      <p:grpSpPr>
+        <a:xfrm>
+          <a:off x="0" y="0"/>
+          <a:ext cx="0" cy="0"/>
+          <a:chOff x="0" y="0"/>
+          <a:chExt cx="0" cy="0"/>
+        </a:xfrm>
+      </p:grpSpPr>
+      <p:pic>
+        <p:nvPicPr>
+          <p:cNvPr id="3" name="Picture 2" descr="The image displays a Dimensional Likert Question interface with five categories (Pain, Itch, and Back) and four response options (C1 to C4) for each category.&#10;&#10;AI-generated content may be incorrect.">
+            <a:extLst>
+              <a:ext uri="{FF2B5EF4-FFF2-40B4-BE49-F238E27FC236}">
+                <a16:creationId xmlns:a16="http://schemas.microsoft.com/office/drawing/2014/main" id="{E642447B-E842-4D52-9916-D26E5F7DF81B}"/>
+              </a:ext>
+            </a:extLst>
+          </p:cNvPr>
+          <p:cNvPicPr>
+            <a:picLocks noChangeAspect="1"/>
+          </p:cNvPicPr>
+          <p:nvPr/>
+        </p:nvPicPr>
+        <p:blipFill>
+          <a:blip r:embed="rId2"/>
+          <a:stretch>
+            <a:fillRect/>
+          </a:stretch>
+        </p:blipFill>
+        <p:spPr>
+          <a:xfrm>
+            <a:off x="3898392" y="4956005"/>
+            <a:ext cx="6136227" cy="4485600"/>
+          </a:xfrm>
+          <a:prstGeom prst="rect">
+            <a:avLst/>
+          </a:prstGeom>
+        </p:spPr>
+      </p:pic>
+      <p:pic>
+        <p:nvPicPr>
+          <p:cNvPr id="5" name="Picture 4" descr="The image displays a Likert scale with five options (C1 to C5) for responding to questions about pain and itch.&#10;&#10;AI-generated content may be incorrect.">
+            <a:extLst>
+              <a:ext uri="{FF2B5EF4-FFF2-40B4-BE49-F238E27FC236}">
+                <a16:creationId xmlns:a16="http://schemas.microsoft.com/office/drawing/2014/main" id="{B154079F-952B-7F52-78E5-97266E6F7996}"/>
+              </a:ext>
+            </a:extLst>
+          </p:cNvPr>
+          <p:cNvPicPr>
+            <a:picLocks noChangeAspect="1"/>
+          </p:cNvPicPr>
+          <p:nvPr/>
+        </p:nvPicPr>
+        <p:blipFill>
+          <a:blip r:embed="rId3"/>
+          <a:stretch>
+            <a:fillRect/>
+          </a:stretch>
+        </p:blipFill>
+        <p:spPr>
+          <a:xfrm>
+            <a:off x="10800556" y="4956005"/>
+            <a:ext cx="7176960" cy="4485600"/>
+          </a:xfrm>
+          <a:prstGeom prst="rect">
+            <a:avLst/>
+          </a:prstGeom>
+        </p:spPr>
+      </p:pic>
+      <p:sp>
+        <p:nvSpPr>
+          <p:cNvPr id="6" name="TextBox 5">
+            <a:extLst>
+              <a:ext uri="{FF2B5EF4-FFF2-40B4-BE49-F238E27FC236}">
+                <a16:creationId xmlns:a16="http://schemas.microsoft.com/office/drawing/2014/main" id="{36112D59-D371-9E77-388D-B0CD557A6EBD}"/>
+              </a:ext>
+            </a:extLst>
+          </p:cNvPr>
+          <p:cNvSpPr txBox="1"/>
+          <p:nvPr/>
+        </p:nvSpPr>
+        <p:spPr>
+          <a:xfrm>
+            <a:off x="3898392" y="4371230"/>
+            <a:ext cx="3090590" cy="584775"/>
+          </a:xfrm>
+          <a:prstGeom prst="rect">
+            <a:avLst/>
+          </a:prstGeom>
+          <a:noFill/>
+        </p:spPr>
+        <p:txBody>
+          <a:bodyPr wrap="none" rtlCol="0">
+            <a:spAutoFit/>
+          </a:bodyPr>
+          <a:lstStyle/>
+          <a:p>
+            <a:r>
+              <a:rPr lang="en-US" sz="3200" dirty="0"/>
+              <a:t>Procedure Panel</a:t>
+            </a:r>
+            <a:endParaRPr lang="en-DK" sz="3200" dirty="0"/>
+          </a:p>
+        </p:txBody>
+      </p:sp>
+      <p:sp>
+        <p:nvSpPr>
+          <p:cNvPr id="7" name="TextBox 6">
+            <a:extLst>
+              <a:ext uri="{FF2B5EF4-FFF2-40B4-BE49-F238E27FC236}">
+                <a16:creationId xmlns:a16="http://schemas.microsoft.com/office/drawing/2014/main" id="{8186A4BF-C2A2-4AB1-D51B-8236693B913D}"/>
+              </a:ext>
+            </a:extLst>
+          </p:cNvPr>
+          <p:cNvSpPr txBox="1"/>
+          <p:nvPr/>
+        </p:nvSpPr>
+        <p:spPr>
+          <a:xfrm>
+            <a:off x="10800556" y="4371230"/>
+            <a:ext cx="3436903" cy="584775"/>
+          </a:xfrm>
+          <a:prstGeom prst="rect">
+            <a:avLst/>
+          </a:prstGeom>
+          <a:noFill/>
+        </p:spPr>
+        <p:txBody>
+          <a:bodyPr wrap="none" rtlCol="0">
+            <a:spAutoFit/>
+          </a:bodyPr>
+          <a:lstStyle/>
+          <a:p>
+            <a:r>
+              <a:rPr lang="en-US" sz="3200" dirty="0"/>
+              <a:t>Participant Screen</a:t>
+            </a:r>
+            <a:endParaRPr lang="en-DK" sz="3200" dirty="0"/>
+          </a:p>
+        </p:txBody>
+      </p:sp>
+    </p:spTree>
+    <p:extLst>
+      <p:ext uri="{BB962C8B-B14F-4D97-AF65-F5344CB8AC3E}">
+        <p14:creationId xmlns:p14="http://schemas.microsoft.com/office/powerpoint/2010/main" val="1657976742"/>
+      </p:ext>
+    </p:extLst>
+  </p:cSld>
+  <p:clrMapOvr>
+    <a:masterClrMapping/>
+  </p:clrMapOvr>
+</p:sld>
+</file>
+
+<file path=ppt/slides/slide8.xml><?xml version="1.0" encoding="utf-8"?>
+<p:sld xmlns:a="http://schemas.openxmlformats.org/drawingml/2006/main" xmlns:r="http://schemas.openxmlformats.org/officeDocument/2006/relationships" xmlns:p="http://schemas.openxmlformats.org/presentationml/2006/main">
+  <p:cSld>
+    <p:spTree>
+      <p:nvGrpSpPr>
+        <p:cNvPr id="1" name=""/>
+        <p:cNvGrpSpPr/>
+        <p:nvPr/>
+      </p:nvGrpSpPr>
+      <p:grpSpPr>
+        <a:xfrm>
+          <a:off x="0" y="0"/>
+          <a:ext cx="0" cy="0"/>
+          <a:chOff x="0" y="0"/>
+          <a:chExt cx="0" cy="0"/>
+        </a:xfrm>
+      </p:grpSpPr>
+      <p:pic>
+        <p:nvPicPr>
+          <p:cNvPr id="3" name="Picture 2" descr="The image shows a webpage with a percentage input field and a dropdown menu for selecting answer options.&#10;&#10;AI-generated content may be incorrect.">
+            <a:extLst>
+              <a:ext uri="{FF2B5EF4-FFF2-40B4-BE49-F238E27FC236}">
+                <a16:creationId xmlns:a16="http://schemas.microsoft.com/office/drawing/2014/main" id="{DEDF16C2-EF88-A0DE-21DD-E6F8CA49001F}"/>
+              </a:ext>
+            </a:extLst>
+          </p:cNvPr>
+          <p:cNvPicPr>
+            <a:picLocks noChangeAspect="1"/>
+          </p:cNvPicPr>
+          <p:nvPr/>
+        </p:nvPicPr>
+        <p:blipFill>
+          <a:blip r:embed="rId2"/>
+          <a:stretch>
+            <a:fillRect/>
+          </a:stretch>
+        </p:blipFill>
+        <p:spPr>
+          <a:xfrm>
+            <a:off x="3898392" y="5114308"/>
+            <a:ext cx="6117576" cy="4485600"/>
+          </a:xfrm>
+          <a:prstGeom prst="rect">
+            <a:avLst/>
+          </a:prstGeom>
+        </p:spPr>
+      </p:pic>
+      <p:pic>
+        <p:nvPicPr>
+          <p:cNvPr id="5" name="Picture 4" descr="The image depicts a user interface with a question prompt and four selectable answer options, labeled as Option 1, Option 2, Option 3, and Option 4, indicating a multiple-choice question where the user must choose one of the four provided answers.&#10;&#10;AI-generated content may be incorrect.">
+            <a:extLst>
+              <a:ext uri="{FF2B5EF4-FFF2-40B4-BE49-F238E27FC236}">
+                <a16:creationId xmlns:a16="http://schemas.microsoft.com/office/drawing/2014/main" id="{F7EF1528-7AB4-F96E-BAA0-CA9D82649A1F}"/>
+              </a:ext>
+            </a:extLst>
+          </p:cNvPr>
+          <p:cNvPicPr>
+            <a:picLocks noChangeAspect="1"/>
+          </p:cNvPicPr>
+          <p:nvPr/>
+        </p:nvPicPr>
+        <p:blipFill>
+          <a:blip r:embed="rId3"/>
+          <a:stretch>
+            <a:fillRect/>
+          </a:stretch>
+        </p:blipFill>
+        <p:spPr>
+          <a:xfrm>
+            <a:off x="10800556" y="5114308"/>
+            <a:ext cx="7176960" cy="4485600"/>
+          </a:xfrm>
+          <a:prstGeom prst="rect">
+            <a:avLst/>
+          </a:prstGeom>
+        </p:spPr>
+      </p:pic>
+      <p:sp>
+        <p:nvSpPr>
+          <p:cNvPr id="6" name="TextBox 5">
+            <a:extLst>
+              <a:ext uri="{FF2B5EF4-FFF2-40B4-BE49-F238E27FC236}">
+                <a16:creationId xmlns:a16="http://schemas.microsoft.com/office/drawing/2014/main" id="{A68CA1B2-2345-A7A9-2964-9DE546CA2D71}"/>
+              </a:ext>
+            </a:extLst>
+          </p:cNvPr>
+          <p:cNvSpPr txBox="1"/>
+          <p:nvPr/>
+        </p:nvSpPr>
+        <p:spPr>
+          <a:xfrm>
+            <a:off x="3898392" y="4371230"/>
+            <a:ext cx="3090590" cy="584775"/>
+          </a:xfrm>
+          <a:prstGeom prst="rect">
+            <a:avLst/>
+          </a:prstGeom>
+          <a:noFill/>
+        </p:spPr>
+        <p:txBody>
+          <a:bodyPr wrap="none" rtlCol="0">
+            <a:spAutoFit/>
+          </a:bodyPr>
+          <a:lstStyle/>
+          <a:p>
+            <a:r>
+              <a:rPr lang="en-US" sz="3200" dirty="0"/>
+              <a:t>Procedure Panel</a:t>
+            </a:r>
+            <a:endParaRPr lang="en-DK" sz="3200" dirty="0"/>
+          </a:p>
+        </p:txBody>
+      </p:sp>
+      <p:sp>
+        <p:nvSpPr>
+          <p:cNvPr id="7" name="TextBox 6">
+            <a:extLst>
+              <a:ext uri="{FF2B5EF4-FFF2-40B4-BE49-F238E27FC236}">
+                <a16:creationId xmlns:a16="http://schemas.microsoft.com/office/drawing/2014/main" id="{1F28DEA7-A5B6-CD7A-87CB-69F4EC4BEE94}"/>
+              </a:ext>
+            </a:extLst>
+          </p:cNvPr>
+          <p:cNvSpPr txBox="1"/>
+          <p:nvPr/>
+        </p:nvSpPr>
+        <p:spPr>
+          <a:xfrm>
+            <a:off x="10800556" y="4371230"/>
+            <a:ext cx="3436903" cy="584775"/>
+          </a:xfrm>
+          <a:prstGeom prst="rect">
+            <a:avLst/>
+          </a:prstGeom>
+          <a:noFill/>
+        </p:spPr>
+        <p:txBody>
+          <a:bodyPr wrap="none" rtlCol="0">
+            <a:spAutoFit/>
+          </a:bodyPr>
+          <a:lstStyle/>
+          <a:p>
+            <a:r>
+              <a:rPr lang="en-US" sz="3200" dirty="0"/>
+              <a:t>Participant Screen</a:t>
+            </a:r>
+            <a:endParaRPr lang="en-DK" sz="3200" dirty="0"/>
+          </a:p>
+        </p:txBody>
+      </p:sp>
+    </p:spTree>
+    <p:extLst>
+      <p:ext uri="{BB962C8B-B14F-4D97-AF65-F5344CB8AC3E}">
+        <p14:creationId xmlns:p14="http://schemas.microsoft.com/office/powerpoint/2010/main" val="2037918701"/>
+      </p:ext>
+    </p:extLst>
+  </p:cSld>
+  <p:clrMapOvr>
+    <a:masterClrMapping/>
+  </p:clrMapOvr>
+</p:sld>
+</file>
+
+<file path=ppt/slides/slide9.xml><?xml version="1.0" encoding="utf-8"?>
+<p:sld xmlns:a="http://schemas.openxmlformats.org/drawingml/2006/main" xmlns:r="http://schemas.openxmlformats.org/officeDocument/2006/relationships" xmlns:p="http://schemas.openxmlformats.org/presentationml/2006/main">
+  <p:cSld>
+    <p:spTree>
+      <p:nvGrpSpPr>
+        <p:cNvPr id="1" name=""/>
+        <p:cNvGrpSpPr/>
+        <p:nvPr/>
+      </p:nvGrpSpPr>
+      <p:grpSpPr>
+        <a:xfrm>
+          <a:off x="0" y="0"/>
+          <a:ext cx="0" cy="0"/>
+          <a:chOff x="0" y="0"/>
+          <a:chExt cx="0" cy="0"/>
+        </a:xfrm>
+      </p:grpSpPr>
+      <p:pic>
+        <p:nvPicPr>
+          <p:cNvPr id="3" name="Picture 2" descr="The image displays a form requesting a time input, with the current time shown as 17:05 on March 25, 2026.&#10;&#10;AI-generated content may be incorrect.">
+            <a:extLst>
+              <a:ext uri="{FF2B5EF4-FFF2-40B4-BE49-F238E27FC236}">
+                <a16:creationId xmlns:a16="http://schemas.microsoft.com/office/drawing/2014/main" id="{3B862C22-5AE6-E330-D2CD-E0B53600C2F4}"/>
+              </a:ext>
+            </a:extLst>
+          </p:cNvPr>
+          <p:cNvPicPr>
+            <a:picLocks noChangeAspect="1"/>
+          </p:cNvPicPr>
+          <p:nvPr/>
+        </p:nvPicPr>
+        <p:blipFill>
+          <a:blip r:embed="rId2"/>
+          <a:stretch>
+            <a:fillRect/>
+          </a:stretch>
+        </p:blipFill>
+        <p:spPr>
+          <a:xfrm>
+            <a:off x="3895568" y="4958608"/>
+            <a:ext cx="6260752" cy="4485600"/>
+          </a:xfrm>
+          <a:prstGeom prst="rect">
+            <a:avLst/>
+          </a:prstGeom>
+        </p:spPr>
+      </p:pic>
+      <p:pic>
+        <p:nvPicPr>
+          <p:cNvPr id="5" name="Picture 4" descr="25/03/2026 17:05:45&#10;&#10;AI-generated content may be incorrect.">
+            <a:extLst>
+              <a:ext uri="{FF2B5EF4-FFF2-40B4-BE49-F238E27FC236}">
+                <a16:creationId xmlns:a16="http://schemas.microsoft.com/office/drawing/2014/main" id="{E5472799-D512-CD38-A3DD-3ED61BF07055}"/>
+              </a:ext>
+            </a:extLst>
+          </p:cNvPr>
+          <p:cNvPicPr>
+            <a:picLocks noChangeAspect="1"/>
+          </p:cNvPicPr>
+          <p:nvPr/>
+        </p:nvPicPr>
+        <p:blipFill>
+          <a:blip r:embed="rId3"/>
+          <a:stretch>
+            <a:fillRect/>
+          </a:stretch>
+        </p:blipFill>
+        <p:spPr>
+          <a:xfrm>
+            <a:off x="10800556" y="4958608"/>
+            <a:ext cx="7176960" cy="4485600"/>
+          </a:xfrm>
+          <a:prstGeom prst="rect">
+            <a:avLst/>
+          </a:prstGeom>
+        </p:spPr>
+      </p:pic>
+      <p:sp>
+        <p:nvSpPr>
+          <p:cNvPr id="6" name="TextBox 5">
+            <a:extLst>
+              <a:ext uri="{FF2B5EF4-FFF2-40B4-BE49-F238E27FC236}">
+                <a16:creationId xmlns:a16="http://schemas.microsoft.com/office/drawing/2014/main" id="{38919670-65DF-E011-0D87-0E6A9A7BE36E}"/>
+              </a:ext>
+            </a:extLst>
+          </p:cNvPr>
+          <p:cNvSpPr txBox="1"/>
+          <p:nvPr/>
+        </p:nvSpPr>
+        <p:spPr>
+          <a:xfrm>
+            <a:off x="3898392" y="4371230"/>
+            <a:ext cx="3090590" cy="584775"/>
+          </a:xfrm>
+          <a:prstGeom prst="rect">
+            <a:avLst/>
+          </a:prstGeom>
+          <a:noFill/>
+        </p:spPr>
+        <p:txBody>
+          <a:bodyPr wrap="none" rtlCol="0">
+            <a:spAutoFit/>
+          </a:bodyPr>
+          <a:lstStyle/>
+          <a:p>
+            <a:r>
+              <a:rPr lang="en-US" sz="3200" dirty="0"/>
+              <a:t>Procedure Panel</a:t>
+            </a:r>
+            <a:endParaRPr lang="en-DK" sz="3200" dirty="0"/>
+          </a:p>
+        </p:txBody>
+      </p:sp>
+      <p:sp>
+        <p:nvSpPr>
+          <p:cNvPr id="7" name="TextBox 6">
+            <a:extLst>
+              <a:ext uri="{FF2B5EF4-FFF2-40B4-BE49-F238E27FC236}">
+                <a16:creationId xmlns:a16="http://schemas.microsoft.com/office/drawing/2014/main" id="{227975FA-6A75-23BE-C223-DAEB6E164318}"/>
+              </a:ext>
+            </a:extLst>
+          </p:cNvPr>
+          <p:cNvSpPr txBox="1"/>
+          <p:nvPr/>
+        </p:nvSpPr>
+        <p:spPr>
+          <a:xfrm>
+            <a:off x="10800556" y="4371230"/>
+            <a:ext cx="3436903" cy="584775"/>
+          </a:xfrm>
+          <a:prstGeom prst="rect">
+            <a:avLst/>
+          </a:prstGeom>
+          <a:noFill/>
+        </p:spPr>
+        <p:txBody>
+          <a:bodyPr wrap="none" rtlCol="0">
+            <a:spAutoFit/>
+          </a:bodyPr>
+          <a:lstStyle/>
+          <a:p>
+            <a:r>
+              <a:rPr lang="en-US" sz="3200" dirty="0"/>
+              <a:t>Participant Screen</a:t>
+            </a:r>
+            <a:endParaRPr lang="en-DK" sz="3200" dirty="0"/>
+          </a:p>
+        </p:txBody>
+      </p:sp>
+    </p:spTree>
+    <p:extLst>
+      <p:ext uri="{BB962C8B-B14F-4D97-AF65-F5344CB8AC3E}">
+        <p14:creationId xmlns:p14="http://schemas.microsoft.com/office/powerpoint/2010/main" val="462970285"/>
       </p:ext>
     </p:extLst>
   </p:cSld>
@@ -5644,6 +7437,15 @@
 </file>
 
 <file path=customXml/item2.xml><?xml version="1.0" encoding="utf-8"?>
+<?mso-contentType ?>
+<FormTemplates xmlns="http://schemas.microsoft.com/sharepoint/v3/contenttype/forms">
+  <Display>DocumentLibraryForm</Display>
+  <Edit>DocumentLibraryForm</Edit>
+  <New>DocumentLibraryForm</New>
+</FormTemplates>
+</file>
+
+<file path=customXml/item3.xml><?xml version="1.0" encoding="utf-8"?>
 <p:properties xmlns:p="http://schemas.microsoft.com/office/2006/metadata/properties" xmlns:xsi="http://www.w3.org/2001/XMLSchema-instance" xmlns:pc="http://schemas.microsoft.com/office/infopath/2007/PartnerControls">
   <documentManagement>
     <TaxCatchAll xmlns="6dfb7b4b-871d-4c24-9d42-16b14ecd044c" xsi:nil="true"/>
@@ -5652,15 +7454,6 @@
     </lcf76f155ced4ddcb4097134ff3c332f>
   </documentManagement>
 </p:properties>
-</file>
-
-<file path=customXml/item3.xml><?xml version="1.0" encoding="utf-8"?>
-<?mso-contentType ?>
-<FormTemplates xmlns="http://schemas.microsoft.com/sharepoint/v3/contenttype/forms">
-  <Display>DocumentLibraryForm</Display>
-  <Edit>DocumentLibraryForm</Edit>
-  <New>DocumentLibraryForm</New>
-</FormTemplates>
 </file>
 
 <file path=customXml/itemProps1.xml><?xml version="1.0" encoding="utf-8"?>
@@ -5683,6 +7476,14 @@
 </file>
 
 <file path=customXml/itemProps2.xml><?xml version="1.0" encoding="utf-8"?>
+<ds:datastoreItem xmlns:ds="http://schemas.openxmlformats.org/officeDocument/2006/customXml" ds:itemID="{EF875D47-8106-485E-98E0-D60C6A98DA6A}">
+  <ds:schemaRefs>
+    <ds:schemaRef ds:uri="http://schemas.microsoft.com/sharepoint/v3/contenttype/forms"/>
+  </ds:schemaRefs>
+</ds:datastoreItem>
+</file>
+
+<file path=customXml/itemProps3.xml><?xml version="1.0" encoding="utf-8"?>
 <ds:datastoreItem xmlns:ds="http://schemas.openxmlformats.org/officeDocument/2006/customXml" ds:itemID="{2EF670CE-B0AA-4D52-AFC6-AA4BF7D46EEA}">
   <ds:schemaRefs>
     <ds:schemaRef ds:uri="http://schemas.microsoft.com/office/2006/metadata/properties"/>
@@ -5691,12 +7492,4 @@
     <ds:schemaRef ds:uri="51c7d8ad-74c8-4833-8478-0d0a5cafce0c"/>
   </ds:schemaRefs>
 </ds:datastoreItem>
-</file>
-
-<file path=customXml/itemProps3.xml><?xml version="1.0" encoding="utf-8"?>
-<ds:datastoreItem xmlns:ds="http://schemas.openxmlformats.org/officeDocument/2006/customXml" ds:itemID="{EF875D47-8106-485E-98E0-D60C6A98DA6A}">
-  <ds:schemaRefs>
-    <ds:schemaRef ds:uri="http://schemas.microsoft.com/sharepoint/v3/contenttype/forms"/>
-  </ds:schemaRefs>
-</ds:datastoreItem>
 </file>
</xml_diff>